<commit_message>
feat(confirm-orders): real fulfill+stock allocations, skip-reason gate, bonus tab, MA timezone
</commit_message>
<xml_diff>
--- a/wholesale_plan_v3.pptx
+++ b/wholesale_plan_v3.pptx
@@ -142,6 +142,35 @@
 </p:presentation>
 </file>
 
+<file path=ppt/changesInfos/changesInfo1.xml><?xml version="1.0" encoding="utf-8"?>
+<pc:chgInfo xmlns:a="http://schemas.openxmlformats.org/drawingml/2006/main" xmlns:r="http://schemas.openxmlformats.org/officeDocument/2006/relationships" xmlns:ac="http://schemas.microsoft.com/office/drawing/2013/main/command" xmlns:pc="http://schemas.microsoft.com/office/powerpoint/2013/main/command">
+  <pc:docChgLst>
+    <pc:chgData name="Kamal SAGUEM" userId="80e1a78e-ec6c-4235-b4a9-581e595c4e42" providerId="ADAL" clId="{FC12CD1E-1BFE-4EF7-B52A-BE7036078183}"/>
+    <pc:docChg chg="modSld">
+      <pc:chgData name="Kamal SAGUEM" userId="80e1a78e-ec6c-4235-b4a9-581e595c4e42" providerId="ADAL" clId="{FC12CD1E-1BFE-4EF7-B52A-BE7036078183}" dt="2026-05-12T22:18:31.747" v="0" actId="1076"/>
+      <pc:docMkLst>
+        <pc:docMk/>
+      </pc:docMkLst>
+      <pc:sldChg chg="modSp mod">
+        <pc:chgData name="Kamal SAGUEM" userId="80e1a78e-ec6c-4235-b4a9-581e595c4e42" providerId="ADAL" clId="{FC12CD1E-1BFE-4EF7-B52A-BE7036078183}" dt="2026-05-12T22:18:31.747" v="0" actId="1076"/>
+        <pc:sldMkLst>
+          <pc:docMk/>
+          <pc:sldMk cId="0" sldId="259"/>
+        </pc:sldMkLst>
+        <pc:spChg chg="mod">
+          <ac:chgData name="Kamal SAGUEM" userId="80e1a78e-ec6c-4235-b4a9-581e595c4e42" providerId="ADAL" clId="{FC12CD1E-1BFE-4EF7-B52A-BE7036078183}" dt="2026-05-12T22:18:31.747" v="0" actId="1076"/>
+          <ac:spMkLst>
+            <pc:docMk/>
+            <pc:sldMk cId="0" sldId="259"/>
+            <ac:spMk id="2" creationId="{00000000-0000-0000-0000-000000000000}"/>
+          </ac:spMkLst>
+        </pc:spChg>
+      </pc:sldChg>
+    </pc:docChg>
+  </pc:docChgLst>
+</pc:chgInfo>
+</file>
+
 <file path=ppt/slideLayouts/slideLayout1.xml><?xml version="1.0" encoding="utf-8"?>
 <p:sldLayout xmlns:a="http://schemas.openxmlformats.org/drawingml/2006/main" xmlns:r="http://schemas.openxmlformats.org/officeDocument/2006/relationships" xmlns:p="http://schemas.openxmlformats.org/presentationml/2006/main" type="title" preserve="1">
   <p:cSld name="Title Slide">
@@ -321,7 +350,7 @@
           <a:p>
             <a:fld id="{5BCAD085-E8A6-8845-BD4E-CB4CCA059FC4}" type="datetimeFigureOut">
               <a:rPr lang="en-US" smtClean="0"/>
-              <a:t>5/8/2026</a:t>
+              <a:t>5/12/2026</a:t>
             </a:fld>
             <a:endParaRPr lang="en-US"/>
           </a:p>
@@ -489,7 +518,7 @@
           <a:p>
             <a:fld id="{5BCAD085-E8A6-8845-BD4E-CB4CCA059FC4}" type="datetimeFigureOut">
               <a:rPr lang="en-US" smtClean="0"/>
-              <a:t>5/8/2026</a:t>
+              <a:t>5/12/2026</a:t>
             </a:fld>
             <a:endParaRPr lang="en-US"/>
           </a:p>
@@ -667,7 +696,7 @@
           <a:p>
             <a:fld id="{5BCAD085-E8A6-8845-BD4E-CB4CCA059FC4}" type="datetimeFigureOut">
               <a:rPr lang="en-US" smtClean="0"/>
-              <a:t>5/8/2026</a:t>
+              <a:t>5/12/2026</a:t>
             </a:fld>
             <a:endParaRPr lang="en-US"/>
           </a:p>
@@ -835,7 +864,7 @@
           <a:p>
             <a:fld id="{5BCAD085-E8A6-8845-BD4E-CB4CCA059FC4}" type="datetimeFigureOut">
               <a:rPr lang="en-US" smtClean="0"/>
-              <a:t>5/8/2026</a:t>
+              <a:t>5/12/2026</a:t>
             </a:fld>
             <a:endParaRPr lang="en-US"/>
           </a:p>
@@ -1080,7 +1109,7 @@
           <a:p>
             <a:fld id="{5BCAD085-E8A6-8845-BD4E-CB4CCA059FC4}" type="datetimeFigureOut">
               <a:rPr lang="en-US" smtClean="0"/>
-              <a:t>5/8/2026</a:t>
+              <a:t>5/12/2026</a:t>
             </a:fld>
             <a:endParaRPr lang="en-US"/>
           </a:p>
@@ -1365,7 +1394,7 @@
           <a:p>
             <a:fld id="{5BCAD085-E8A6-8845-BD4E-CB4CCA059FC4}" type="datetimeFigureOut">
               <a:rPr lang="en-US" smtClean="0"/>
-              <a:t>5/8/2026</a:t>
+              <a:t>5/12/2026</a:t>
             </a:fld>
             <a:endParaRPr lang="en-US"/>
           </a:p>
@@ -1784,7 +1813,7 @@
           <a:p>
             <a:fld id="{5BCAD085-E8A6-8845-BD4E-CB4CCA059FC4}" type="datetimeFigureOut">
               <a:rPr lang="en-US" smtClean="0"/>
-              <a:t>5/8/2026</a:t>
+              <a:t>5/12/2026</a:t>
             </a:fld>
             <a:endParaRPr lang="en-US"/>
           </a:p>
@@ -1901,7 +1930,7 @@
           <a:p>
             <a:fld id="{5BCAD085-E8A6-8845-BD4E-CB4CCA059FC4}" type="datetimeFigureOut">
               <a:rPr lang="en-US" smtClean="0"/>
-              <a:t>5/8/2026</a:t>
+              <a:t>5/12/2026</a:t>
             </a:fld>
             <a:endParaRPr lang="en-US"/>
           </a:p>
@@ -1996,7 +2025,7 @@
           <a:p>
             <a:fld id="{5BCAD085-E8A6-8845-BD4E-CB4CCA059FC4}" type="datetimeFigureOut">
               <a:rPr lang="en-US" smtClean="0"/>
-              <a:t>5/8/2026</a:t>
+              <a:t>5/12/2026</a:t>
             </a:fld>
             <a:endParaRPr lang="en-US"/>
           </a:p>
@@ -2271,7 +2300,7 @@
           <a:p>
             <a:fld id="{5BCAD085-E8A6-8845-BD4E-CB4CCA059FC4}" type="datetimeFigureOut">
               <a:rPr lang="en-US" smtClean="0"/>
-              <a:t>5/8/2026</a:t>
+              <a:t>5/12/2026</a:t>
             </a:fld>
             <a:endParaRPr lang="en-US"/>
           </a:p>
@@ -2523,7 +2552,7 @@
           <a:p>
             <a:fld id="{5BCAD085-E8A6-8845-BD4E-CB4CCA059FC4}" type="datetimeFigureOut">
               <a:rPr lang="en-US" smtClean="0"/>
-              <a:t>5/8/2026</a:t>
+              <a:t>5/12/2026</a:t>
             </a:fld>
             <a:endParaRPr lang="en-US"/>
           </a:p>
@@ -2734,7 +2763,7 @@
           <a:p>
             <a:fld id="{5BCAD085-E8A6-8845-BD4E-CB4CCA059FC4}" type="datetimeFigureOut">
               <a:rPr lang="en-US" smtClean="0"/>
-              <a:t>5/8/2026</a:t>
+              <a:t>5/12/2026</a:t>
             </a:fld>
             <a:endParaRPr lang="en-US"/>
           </a:p>
@@ -14823,7 +14852,7 @@
         </p:nvSpPr>
         <p:spPr>
           <a:xfrm>
-            <a:off x="0" y="0"/>
+            <a:off x="672920" y="304960"/>
             <a:ext cx="12191695" cy="6858000"/>
           </a:xfrm>
           <a:prstGeom prst="rect">

</xml_diff>